<commit_message>
Normalize DOCX and PPTX deliverables
DOCX: drafting notes (chapter-top quotes, editorial reminders,
abstract/TOC nags) no longer render; figure anchor lines are
replaced by the embedded image + caption so no repo file names
leak into the prose; numbered lists render as numbered
paragraphs instead of double-marked bullets; real quote blocks
(appendix E) render as indented quotes; headings gained
keep-with-next and spacing; page-number footer added; tables
with 7+ columns drop to 10pt so Table 2.1 fits the page.

PPTX: recomputed geometry removes image overlaps on slides 2, 7
and 12, the RQ1 chart no longer collides with its takeaway line,
and all takeaway blocks fit above the bottom edge. A programmatic
checker over all 23 slides now reports no out-of-bounds shapes
and no picture overlaps.
</commit_message>
<xml_diff>
--- a/docs/bao-cao/slide-bao-ve.pptx
+++ b/docs/bao-cao/slide-bao-ve.pptx
@@ -3427,7 +3427,7 @@
         </p:nvSpPr>
         <p:spPr>
           <a:xfrm>
-            <a:off x="502920" y="5669280"/>
+            <a:off x="502920" y="5577840"/>
             <a:ext cx="11155680" cy="914400"/>
           </a:xfrm>
           <a:prstGeom prst="rect">
@@ -3466,7 +3466,7 @@
         </p:nvSpPr>
         <p:spPr>
           <a:xfrm>
-            <a:off x="502920" y="6355080"/>
+            <a:off x="502920" y="6263640"/>
             <a:ext cx="11155680" cy="548640"/>
           </a:xfrm>
           <a:prstGeom prst="rect">
@@ -3839,8 +3839,8 @@
         </p:blipFill>
         <p:spPr>
           <a:xfrm>
-            <a:off x="8549640" y="1325880"/>
-            <a:ext cx="3200400" cy="2750343"/>
+            <a:off x="8869680" y="1234440"/>
+            <a:ext cx="2331720" cy="2003821"/>
           </a:xfrm>
           <a:prstGeom prst="rect">
             <a:avLst/>
@@ -3863,8 +3863,8 @@
         </p:blipFill>
         <p:spPr>
           <a:xfrm>
-            <a:off x="8549640" y="3429000"/>
-            <a:ext cx="3200400" cy="2750343"/>
+            <a:off x="8869680" y="3291840"/>
+            <a:ext cx="2331720" cy="2003821"/>
           </a:xfrm>
           <a:prstGeom prst="rect">
             <a:avLst/>
@@ -3879,8 +3879,8 @@
         </p:nvSpPr>
         <p:spPr>
           <a:xfrm>
-            <a:off x="8549640" y="5440680"/>
-            <a:ext cx="3200400" cy="457200"/>
+            <a:off x="8595360" y="5321808"/>
+            <a:ext cx="3108960" cy="292608"/>
           </a:xfrm>
           <a:prstGeom prst="rect">
             <a:avLst/>
@@ -3899,7 +3899,7 @@
               </a:spcAft>
             </a:pPr>
             <a:r>
-              <a:rPr sz="1200" b="0">
+              <a:rPr sz="1100" b="0">
                 <a:solidFill>
                   <a:srgbClr val="595959"/>
                 </a:solidFill>
@@ -3918,7 +3918,7 @@
         </p:nvSpPr>
         <p:spPr>
           <a:xfrm>
-            <a:off x="502920" y="5806440"/>
+            <a:off x="502920" y="5623560"/>
             <a:ext cx="11155680" cy="914400"/>
           </a:xfrm>
           <a:prstGeom prst="rect">
@@ -3957,7 +3957,7 @@
         </p:nvSpPr>
         <p:spPr>
           <a:xfrm>
-            <a:off x="502920" y="6492240"/>
+            <a:off x="502920" y="6309360"/>
             <a:ext cx="11155680" cy="548640"/>
           </a:xfrm>
           <a:prstGeom prst="rect">
@@ -6352,8 +6352,8 @@
         </p:blipFill>
         <p:spPr>
           <a:xfrm>
-            <a:off x="6400800" y="1371600"/>
-            <a:ext cx="5303520" cy="4056364"/>
+            <a:off x="6309360" y="1325880"/>
+            <a:ext cx="3017520" cy="2307931"/>
           </a:xfrm>
           <a:prstGeom prst="rect">
             <a:avLst/>
@@ -6368,8 +6368,8 @@
         </p:nvSpPr>
         <p:spPr>
           <a:xfrm>
-            <a:off x="6400800" y="4434840"/>
-            <a:ext cx="5303520" cy="365760"/>
+            <a:off x="9464040" y="2194560"/>
+            <a:ext cx="2377440" cy="1371600"/>
           </a:xfrm>
           <a:prstGeom prst="rect">
             <a:avLst/>
@@ -6415,8 +6415,8 @@
         </p:blipFill>
         <p:spPr>
           <a:xfrm>
-            <a:off x="6400800" y="4754880"/>
-            <a:ext cx="4023360" cy="3262693"/>
+            <a:off x="6309360" y="4069080"/>
+            <a:ext cx="3017520" cy="2447020"/>
           </a:xfrm>
           <a:prstGeom prst="rect">
             <a:avLst/>
@@ -6431,8 +6431,8 @@
         </p:nvSpPr>
         <p:spPr>
           <a:xfrm>
-            <a:off x="10469880" y="5394960"/>
-            <a:ext cx="1645920" cy="914400"/>
+            <a:off x="9464040" y="4937760"/>
+            <a:ext cx="2377440" cy="1463040"/>
           </a:xfrm>
           <a:prstGeom prst="rect">
             <a:avLst/>
@@ -9147,7 +9147,7 @@
         <p:spPr>
           <a:xfrm>
             <a:off x="502920" y="3063240"/>
-            <a:ext cx="11155680" cy="4937760"/>
+            <a:ext cx="11155680" cy="3566160"/>
           </a:xfrm>
           <a:prstGeom prst="rect">
             <a:avLst/>
@@ -9341,8 +9341,8 @@
         </p:blipFill>
         <p:spPr>
           <a:xfrm>
-            <a:off x="502920" y="1371600"/>
-            <a:ext cx="4297680" cy="3287053"/>
+            <a:off x="502920" y="1188720"/>
+            <a:ext cx="2926080" cy="2237994"/>
           </a:xfrm>
           <a:prstGeom prst="rect">
             <a:avLst/>
@@ -9357,8 +9357,8 @@
         </p:nvSpPr>
         <p:spPr>
           <a:xfrm>
-            <a:off x="4846320" y="2194560"/>
-            <a:ext cx="1554480" cy="1280160"/>
+            <a:off x="3520439" y="2011680"/>
+            <a:ext cx="2651760" cy="1280160"/>
           </a:xfrm>
           <a:prstGeom prst="rect">
             <a:avLst/>
@@ -9404,8 +9404,8 @@
         </p:blipFill>
         <p:spPr>
           <a:xfrm>
-            <a:off x="6355080" y="1371600"/>
-            <a:ext cx="4297680" cy="3287053"/>
+            <a:off x="6355080" y="1188720"/>
+            <a:ext cx="2926080" cy="2237994"/>
           </a:xfrm>
           <a:prstGeom prst="rect">
             <a:avLst/>
@@ -9420,8 +9420,8 @@
         </p:nvSpPr>
         <p:spPr>
           <a:xfrm>
-            <a:off x="10698480" y="2194560"/>
-            <a:ext cx="1554480" cy="1280160"/>
+            <a:off x="9372600" y="2011680"/>
+            <a:ext cx="2651760" cy="1280160"/>
           </a:xfrm>
           <a:prstGeom prst="rect">
             <a:avLst/>
@@ -9468,7 +9468,7 @@
         <p:spPr>
           <a:xfrm>
             <a:off x="502920" y="3977639"/>
-            <a:ext cx="4297680" cy="3485149"/>
+            <a:ext cx="2926080" cy="2372868"/>
           </a:xfrm>
           <a:prstGeom prst="rect">
             <a:avLst/>
@@ -9483,8 +9483,8 @@
         </p:nvSpPr>
         <p:spPr>
           <a:xfrm>
-            <a:off x="4846320" y="4800600"/>
-            <a:ext cx="1554480" cy="1280160"/>
+            <a:off x="3520439" y="4800600"/>
+            <a:ext cx="2651760" cy="1280160"/>
           </a:xfrm>
           <a:prstGeom prst="rect">
             <a:avLst/>
@@ -9531,7 +9531,7 @@
         <p:spPr>
           <a:xfrm>
             <a:off x="6355080" y="3977639"/>
-            <a:ext cx="4297680" cy="3287053"/>
+            <a:ext cx="2926080" cy="2237994"/>
           </a:xfrm>
           <a:prstGeom prst="rect">
             <a:avLst/>
@@ -9546,8 +9546,8 @@
         </p:nvSpPr>
         <p:spPr>
           <a:xfrm>
-            <a:off x="10698480" y="4800600"/>
-            <a:ext cx="1554480" cy="1280160"/>
+            <a:off x="9372600" y="4800600"/>
+            <a:ext cx="2651760" cy="1280160"/>
           </a:xfrm>
           <a:prstGeom prst="rect">
             <a:avLst/>
@@ -9585,8 +9585,8 @@
         </p:nvSpPr>
         <p:spPr>
           <a:xfrm>
-            <a:off x="502920" y="6400800"/>
-            <a:ext cx="11155680" cy="365760"/>
+            <a:off x="502920" y="6510528"/>
+            <a:ext cx="11155680" cy="320040"/>
           </a:xfrm>
           <a:prstGeom prst="rect">
             <a:avLst/>
@@ -9605,7 +9605,7 @@
               </a:spcAft>
             </a:pPr>
             <a:r>
-              <a:rPr sz="1300" b="0">
+              <a:rPr sz="1200" b="0">
                 <a:solidFill>
                   <a:srgbClr val="595959"/>
                 </a:solidFill>
@@ -9771,8 +9771,8 @@
         </p:blipFill>
         <p:spPr>
           <a:xfrm>
-            <a:off x="2148840" y="1234440"/>
-            <a:ext cx="7863840" cy="4718304"/>
+            <a:off x="2715768" y="1234440"/>
+            <a:ext cx="6766560" cy="4059936"/>
           </a:xfrm>
           <a:prstGeom prst="rect">
             <a:avLst/>
@@ -9787,7 +9787,7 @@
         </p:nvSpPr>
         <p:spPr>
           <a:xfrm>
-            <a:off x="502920" y="5760720"/>
+            <a:off x="502920" y="5486400"/>
             <a:ext cx="11155680" cy="914400"/>
           </a:xfrm>
           <a:prstGeom prst="rect">
@@ -9826,7 +9826,7 @@
         </p:nvSpPr>
         <p:spPr>
           <a:xfrm>
-            <a:off x="502920" y="6446520"/>
+            <a:off x="502920" y="6172200"/>
             <a:ext cx="11155680" cy="548640"/>
           </a:xfrm>
           <a:prstGeom prst="rect">
@@ -9989,7 +9989,7 @@
         </p:nvSpPr>
         <p:spPr>
           <a:xfrm>
-            <a:off x="502920" y="5715000"/>
+            <a:off x="502920" y="5577840"/>
             <a:ext cx="11155680" cy="914400"/>
           </a:xfrm>
           <a:prstGeom prst="rect">
@@ -10028,7 +10028,7 @@
         </p:nvSpPr>
         <p:spPr>
           <a:xfrm>
-            <a:off x="502920" y="6400800"/>
+            <a:off x="502920" y="6263640"/>
             <a:ext cx="11155680" cy="548640"/>
           </a:xfrm>
           <a:prstGeom prst="rect">

</xml_diff>